<commit_message>
W02 D2 S14 chart gets a legend; both decks rebuilt
The bars are titled collected as reported and the line booked, so mermaid draws the key.
Decks rebuilt with mermaid-cli 11.17.0.

Co-Authored-By: Claude Opus 5.5 <noreply@anthropic.com>
Claude-Session: https://claude.ai/code/session_01FMquSzJHb1y87KeC5n3yVd
</commit_message>
<xml_diff>
--- a/content/W02/D2/slides/C2_W02_D02_half1_STUDENT.pptx
+++ b/content/W02/D2/slides/C2_W02_D02_half1_STUDENT.pptx
@@ -10632,8 +10632,8 @@
         </p:blipFill>
         <p:spPr>
           <a:xfrm>
-            <a:off x="951840" y="2119407"/>
-            <a:ext cx="3943350" cy="3643312"/>
+            <a:off x="4192317" y="1664208"/>
+            <a:ext cx="3807059" cy="3517392"/>
           </a:xfrm>
           <a:prstGeom prst="rect">
             <a:avLst/>
@@ -10648,8 +10648,8 @@
         </p:nvSpPr>
         <p:spPr>
           <a:xfrm>
-            <a:off x="5761917" y="1956816"/>
-            <a:ext cx="5899425" cy="1074420"/>
+            <a:off x="530352" y="5227320"/>
+            <a:ext cx="11130991" cy="807720"/>
           </a:xfrm>
           <a:prstGeom prst="roundRect">
             <a:avLst>
@@ -10696,8 +10696,8 @@
         </p:nvSpPr>
         <p:spPr>
           <a:xfrm>
-            <a:off x="5908221" y="2084832"/>
-            <a:ext cx="45720" cy="818388"/>
+            <a:off x="676656" y="5355336"/>
+            <a:ext cx="45720" cy="551688"/>
           </a:xfrm>
           <a:prstGeom prst="roundRect">
             <a:avLst>
@@ -10742,8 +10742,8 @@
         </p:nvSpPr>
         <p:spPr>
           <a:xfrm>
-            <a:off x="6109389" y="2075688"/>
-            <a:ext cx="5332497" cy="891540"/>
+            <a:off x="877824" y="5346192"/>
+            <a:ext cx="10564063" cy="624840"/>
           </a:xfrm>
           <a:prstGeom prst="rect">
             <a:avLst/>
@@ -16772,7 +16772,7 @@
       </p:sp>
       <p:pic>
         <p:nvPicPr>
-          <p:cNvPr id="21" name="mermaid diagram" descr="9d9410948b6115af.png"/>
+          <p:cNvPr id="21" name="mermaid diagram" descr="31cfe99f33ea4d24.png"/>
           <p:cNvPicPr>
             <a:picLocks noChangeAspect="1"/>
           </p:cNvPicPr>
@@ -20003,7 +20003,7 @@
                 </a:solidFill>
                 <a:latin typeface="Calibri"/>
               </a:rPr>
-              <a:t>Week 2 Day 2: booked against collected</a:t>
+              <a:t>Week 2, Day 2. Booked against collected, without lying</a:t>
             </a:r>
           </a:p>
         </p:txBody>
@@ -24226,7 +24226,7 @@
                 </a:solidFill>
                 <a:latin typeface="Calibri"/>
               </a:rPr>
-              <a:t>Week 2 Day 2: booked against collected</a:t>
+              <a:t>Week 2, Day 2. Booked against collected, without lying</a:t>
             </a:r>
           </a:p>
         </p:txBody>
@@ -36987,7 +36987,7 @@
                 </a:solidFill>
                 <a:latin typeface="Calibri"/>
               </a:rPr>
-              <a:t>Week 2 Day 2: booked against collected</a:t>
+              <a:t>Week 2, Day 2. Booked against collected, without lying</a:t>
             </a:r>
           </a:p>
         </p:txBody>
@@ -54843,7 +54843,7 @@
                 </a:solidFill>
                 <a:latin typeface="Calibri"/>
               </a:rPr>
-              <a:t>[D] Design the validation you run before a joined number reaches Finance, and say what you do when it fails at 5 pm on reporting day.</a:t>
+              <a:t>[D] Design the validation you run before a joined number reaches Finance, and say what you do when it fails at the end of reporting day.</a:t>
             </a:r>
           </a:p>
         </p:txBody>
@@ -55725,7 +55725,7 @@
                 </a:solidFill>
                 <a:latin typeface="Calibri"/>
               </a:rPr>
-              <a:t>Week 2 Day 2: booked against collected</a:t>
+              <a:t>Week 2, Day 2. Booked against collected, without lying</a:t>
             </a:r>
           </a:p>
         </p:txBody>

</xml_diff>